<commit_message>
update paper for lecture 2
</commit_message>
<xml_diff>
--- a/papers/lektion-2.pptx
+++ b/papers/lektion-2.pptx
@@ -12,12 +12,12 @@
   </p:handoutMasterIdLst>
   <p:sldIdLst>
     <p:sldId id="256" r:id="rId5"/>
-    <p:sldId id="309" r:id="rId6"/>
-    <p:sldId id="303" r:id="rId7"/>
-    <p:sldId id="307" r:id="rId8"/>
-    <p:sldId id="308" r:id="rId9"/>
-    <p:sldId id="310" r:id="rId10"/>
-    <p:sldId id="311" r:id="rId11"/>
+    <p:sldId id="312" r:id="rId6"/>
+    <p:sldId id="309" r:id="rId7"/>
+    <p:sldId id="303" r:id="rId8"/>
+    <p:sldId id="307" r:id="rId9"/>
+    <p:sldId id="308" r:id="rId10"/>
+    <p:sldId id="310" r:id="rId11"/>
     <p:sldId id="295" r:id="rId12"/>
     <p:sldId id="298" r:id="rId13"/>
     <p:sldId id="272" r:id="rId14"/>
@@ -129,6 +129,7 @@
         </p14:section>
         <p14:section name="Recap" id="{9D3D6EE0-2854-49B6-8A11-D3333306B6B7}">
           <p14:sldIdLst>
+            <p14:sldId id="312"/>
             <p14:sldId id="309"/>
             <p14:sldId id="303"/>
             <p14:sldId id="307"/>
@@ -138,7 +139,6 @@
           <p14:sldIdLst>
             <p14:sldId id="308"/>
             <p14:sldId id="310"/>
-            <p14:sldId id="311"/>
           </p14:sldIdLst>
         </p14:section>
         <p14:section name="Abschluss" id="{BDD9CAB4-1E85-4AAD-9582-8A028B42FA47}">
@@ -242,7 +242,7 @@
           <a:p>
             <a:fld id="{FC23D672-218E-44CF-A13C-71AB61B14F4F}" type="datetimeFigureOut">
               <a:rPr lang="de-CH" smtClean="0"/>
-              <a:t>21.01.2025</a:t>
+              <a:t>27.01.2025</a:t>
             </a:fld>
             <a:endParaRPr lang="de-CH"/>
           </a:p>
@@ -407,7 +407,7 @@
           <a:p>
             <a:fld id="{93FA598B-8DA1-4BBA-9EA9-DC1615E9868A}" type="datetimeFigureOut">
               <a:rPr lang="de-CH" smtClean="0"/>
-              <a:t>21.01.2025</a:t>
+              <a:t>27.01.2025</a:t>
             </a:fld>
             <a:endParaRPr lang="de-CH"/>
           </a:p>
@@ -768,7 +768,13 @@
   <p:cSld>
     <p:spTree>
       <p:nvGrpSpPr>
-        <p:cNvPr id="1" name=""/>
+        <p:cNvPr id="1" name="">
+          <a:extLst>
+            <a:ext uri="{FF2B5EF4-FFF2-40B4-BE49-F238E27FC236}">
+              <a16:creationId xmlns:a16="http://schemas.microsoft.com/office/drawing/2014/main" id="{1FCC007E-1867-744D-832E-2E2E0E33B68C}"/>
+            </a:ext>
+          </a:extLst>
+        </p:cNvPr>
         <p:cNvGrpSpPr/>
         <p:nvPr/>
       </p:nvGrpSpPr>
@@ -782,7 +788,13 @@
       </p:grpSpPr>
       <p:sp>
         <p:nvSpPr>
-          <p:cNvPr id="2" name="Folienbildplatzhalter 1"/>
+          <p:cNvPr id="2" name="Folienbildplatzhalter 1">
+            <a:extLst>
+              <a:ext uri="{FF2B5EF4-FFF2-40B4-BE49-F238E27FC236}">
+                <a16:creationId xmlns:a16="http://schemas.microsoft.com/office/drawing/2014/main" id="{8F36001A-3549-C688-5693-BC133242EADB}"/>
+              </a:ext>
+            </a:extLst>
+          </p:cNvPr>
           <p:cNvSpPr>
             <a:spLocks noGrp="1" noRot="1" noChangeAspect="1"/>
           </p:cNvSpPr>
@@ -794,7 +806,13 @@
       </p:sp>
       <p:sp>
         <p:nvSpPr>
-          <p:cNvPr id="3" name="Notizenplatzhalter 2"/>
+          <p:cNvPr id="3" name="Notizenplatzhalter 2">
+            <a:extLst>
+              <a:ext uri="{FF2B5EF4-FFF2-40B4-BE49-F238E27FC236}">
+                <a16:creationId xmlns:a16="http://schemas.microsoft.com/office/drawing/2014/main" id="{2EB05B71-E72A-7EFE-C205-24C14E647F8C}"/>
+              </a:ext>
+            </a:extLst>
+          </p:cNvPr>
           <p:cNvSpPr>
             <a:spLocks noGrp="1"/>
           </p:cNvSpPr>
@@ -813,7 +831,13 @@
       </p:sp>
       <p:sp>
         <p:nvSpPr>
-          <p:cNvPr id="4" name="Foliennummernplatzhalter 3"/>
+          <p:cNvPr id="4" name="Foliennummernplatzhalter 3">
+            <a:extLst>
+              <a:ext uri="{FF2B5EF4-FFF2-40B4-BE49-F238E27FC236}">
+                <a16:creationId xmlns:a16="http://schemas.microsoft.com/office/drawing/2014/main" id="{C4C03071-EFAD-0F33-2347-CCCADB4296EA}"/>
+              </a:ext>
+            </a:extLst>
+          </p:cNvPr>
           <p:cNvSpPr>
             <a:spLocks noGrp="1"/>
           </p:cNvSpPr>
@@ -837,7 +861,7 @@
     </p:spTree>
     <p:extLst>
       <p:ext uri="{BB962C8B-B14F-4D97-AF65-F5344CB8AC3E}">
-        <p14:creationId xmlns:p14="http://schemas.microsoft.com/office/powerpoint/2010/main" val="3748463550"/>
+        <p14:creationId xmlns:p14="http://schemas.microsoft.com/office/powerpoint/2010/main" val="1466191987"/>
       </p:ext>
     </p:extLst>
   </p:cSld>
@@ -912,7 +936,7 @@
           <a:p>
             <a:fld id="{9B3C940E-24E7-4D1A-B11D-DBBBB544974E}" type="slidenum">
               <a:rPr lang="de-CH" smtClean="0"/>
-              <a:t>5</a:t>
+              <a:t>3</a:t>
             </a:fld>
             <a:endParaRPr lang="de-CH"/>
           </a:p>
@@ -921,7 +945,7 @@
     </p:spTree>
     <p:extLst>
       <p:ext uri="{BB962C8B-B14F-4D97-AF65-F5344CB8AC3E}">
-        <p14:creationId xmlns:p14="http://schemas.microsoft.com/office/powerpoint/2010/main" val="3069967177"/>
+        <p14:creationId xmlns:p14="http://schemas.microsoft.com/office/powerpoint/2010/main" val="3748463550"/>
       </p:ext>
     </p:extLst>
   </p:cSld>
@@ -975,10 +999,6 @@
           <a:bodyPr/>
           <a:lstStyle/>
           <a:p>
-            <a:r>
-              <a:rPr lang="de-CH" dirty="0"/>
-              <a:t>15:50</a:t>
-            </a:r>
             <a:endParaRPr lang="LID4096" dirty="0"/>
           </a:p>
         </p:txBody>
@@ -1000,7 +1020,7 @@
           <a:p>
             <a:fld id="{9B3C940E-24E7-4D1A-B11D-DBBBB544974E}" type="slidenum">
               <a:rPr lang="de-CH" smtClean="0"/>
-              <a:t>8</a:t>
+              <a:t>6</a:t>
             </a:fld>
             <a:endParaRPr lang="de-CH"/>
           </a:p>
@@ -1009,7 +1029,7 @@
     </p:spTree>
     <p:extLst>
       <p:ext uri="{BB962C8B-B14F-4D97-AF65-F5344CB8AC3E}">
-        <p14:creationId xmlns:p14="http://schemas.microsoft.com/office/powerpoint/2010/main" val="574930870"/>
+        <p14:creationId xmlns:p14="http://schemas.microsoft.com/office/powerpoint/2010/main" val="3069967177"/>
       </p:ext>
     </p:extLst>
   </p:cSld>
@@ -1088,6 +1108,94 @@
           <a:p>
             <a:fld id="{9B3C940E-24E7-4D1A-B11D-DBBBB544974E}" type="slidenum">
               <a:rPr lang="de-CH" smtClean="0"/>
+              <a:t>8</a:t>
+            </a:fld>
+            <a:endParaRPr lang="de-CH"/>
+          </a:p>
+        </p:txBody>
+      </p:sp>
+    </p:spTree>
+    <p:extLst>
+      <p:ext uri="{BB962C8B-B14F-4D97-AF65-F5344CB8AC3E}">
+        <p14:creationId xmlns:p14="http://schemas.microsoft.com/office/powerpoint/2010/main" val="574930870"/>
+      </p:ext>
+    </p:extLst>
+  </p:cSld>
+  <p:clrMapOvr>
+    <a:masterClrMapping/>
+  </p:clrMapOvr>
+</p:notes>
+</file>
+
+<file path=ppt/notesSlides/notesSlide6.xml><?xml version="1.0" encoding="utf-8"?>
+<p:notes xmlns:a="http://schemas.openxmlformats.org/drawingml/2006/main" xmlns:r="http://schemas.openxmlformats.org/officeDocument/2006/relationships" xmlns:p="http://schemas.openxmlformats.org/presentationml/2006/main">
+  <p:cSld>
+    <p:spTree>
+      <p:nvGrpSpPr>
+        <p:cNvPr id="1" name=""/>
+        <p:cNvGrpSpPr/>
+        <p:nvPr/>
+      </p:nvGrpSpPr>
+      <p:grpSpPr>
+        <a:xfrm>
+          <a:off x="0" y="0"/>
+          <a:ext cx="0" cy="0"/>
+          <a:chOff x="0" y="0"/>
+          <a:chExt cx="0" cy="0"/>
+        </a:xfrm>
+      </p:grpSpPr>
+      <p:sp>
+        <p:nvSpPr>
+          <p:cNvPr id="2" name="Folienbildplatzhalter 1"/>
+          <p:cNvSpPr>
+            <a:spLocks noGrp="1" noRot="1" noChangeAspect="1"/>
+          </p:cNvSpPr>
+          <p:nvPr>
+            <p:ph type="sldImg"/>
+          </p:nvPr>
+        </p:nvSpPr>
+        <p:spPr/>
+      </p:sp>
+      <p:sp>
+        <p:nvSpPr>
+          <p:cNvPr id="3" name="Notizenplatzhalter 2"/>
+          <p:cNvSpPr>
+            <a:spLocks noGrp="1"/>
+          </p:cNvSpPr>
+          <p:nvPr>
+            <p:ph type="body" idx="1"/>
+          </p:nvPr>
+        </p:nvSpPr>
+        <p:spPr/>
+        <p:txBody>
+          <a:bodyPr/>
+          <a:lstStyle/>
+          <a:p>
+            <a:r>
+              <a:rPr lang="de-CH" dirty="0"/>
+              <a:t>15:50</a:t>
+            </a:r>
+            <a:endParaRPr lang="LID4096" dirty="0"/>
+          </a:p>
+        </p:txBody>
+      </p:sp>
+      <p:sp>
+        <p:nvSpPr>
+          <p:cNvPr id="4" name="Foliennummernplatzhalter 3"/>
+          <p:cNvSpPr>
+            <a:spLocks noGrp="1"/>
+          </p:cNvSpPr>
+          <p:nvPr>
+            <p:ph type="sldNum" sz="quarter" idx="5"/>
+          </p:nvPr>
+        </p:nvSpPr>
+        <p:spPr/>
+        <p:txBody>
+          <a:bodyPr/>
+          <a:lstStyle/>
+          <a:p>
+            <a:fld id="{9B3C940E-24E7-4D1A-B11D-DBBBB544974E}" type="slidenum">
+              <a:rPr lang="de-CH" smtClean="0"/>
               <a:t>9</a:t>
             </a:fld>
             <a:endParaRPr lang="de-CH"/>
@@ -1107,7 +1215,7 @@
 </p:notes>
 </file>
 
-<file path=ppt/notesSlides/notesSlide6.xml><?xml version="1.0" encoding="utf-8"?>
+<file path=ppt/notesSlides/notesSlide7.xml><?xml version="1.0" encoding="utf-8"?>
 <p:notes xmlns:a="http://schemas.openxmlformats.org/drawingml/2006/main" xmlns:r="http://schemas.openxmlformats.org/officeDocument/2006/relationships" xmlns:p="http://schemas.openxmlformats.org/presentationml/2006/main">
   <p:cSld>
     <p:spTree>
@@ -1397,7 +1505,7 @@
           <a:p>
             <a:fld id="{6853F526-C1D0-4550-B781-F5C2F41E5AD9}" type="datetime1">
               <a:rPr lang="de-CH" smtClean="0"/>
-              <a:t>21.01.2025</a:t>
+              <a:t>27.01.2025</a:t>
             </a:fld>
             <a:endParaRPr lang="de-CH"/>
           </a:p>
@@ -1533,7 +1641,7 @@
           <a:p>
             <a:fld id="{A1523D7E-84BA-4532-8AC0-0461707F3C45}" type="datetime1">
               <a:rPr lang="de-CH" smtClean="0"/>
-              <a:t>21.01.2025</a:t>
+              <a:t>27.01.2025</a:t>
             </a:fld>
             <a:endParaRPr lang="de-CH"/>
           </a:p>
@@ -1691,7 +1799,7 @@
           <a:p>
             <a:fld id="{A1523D7E-84BA-4532-8AC0-0461707F3C45}" type="datetime1">
               <a:rPr lang="de-CH" smtClean="0"/>
-              <a:t>21.01.2025</a:t>
+              <a:t>27.01.2025</a:t>
             </a:fld>
             <a:endParaRPr lang="de-CH"/>
           </a:p>
@@ -2319,7 +2427,7 @@
           <a:p>
             <a:fld id="{107B2E98-33F3-4843-92CD-A9A795F13784}" type="datetime1">
               <a:rPr lang="de-CH" smtClean="0"/>
-              <a:t>21.01.2025</a:t>
+              <a:t>27.01.2025</a:t>
             </a:fld>
             <a:endParaRPr lang="de-CH"/>
           </a:p>
@@ -2448,7 +2556,7 @@
           <a:p>
             <a:fld id="{A1523D7E-84BA-4532-8AC0-0461707F3C45}" type="datetime1">
               <a:rPr lang="de-CH" smtClean="0"/>
-              <a:t>21.01.2025</a:t>
+              <a:t>27.01.2025</a:t>
             </a:fld>
             <a:endParaRPr lang="de-CH"/>
           </a:p>
@@ -3090,7 +3198,7 @@
           <a:p>
             <a:fld id="{6853F526-C1D0-4550-B781-F5C2F41E5AD9}" type="datetime1">
               <a:rPr lang="de-CH" smtClean="0"/>
-              <a:t>21.01.2025</a:t>
+              <a:t>27.01.2025</a:t>
             </a:fld>
             <a:endParaRPr lang="de-CH"/>
           </a:p>
@@ -3226,7 +3334,7 @@
           <a:p>
             <a:fld id="{A1523D7E-84BA-4532-8AC0-0461707F3C45}" type="datetime1">
               <a:rPr lang="de-CH" smtClean="0"/>
-              <a:t>21.01.2025</a:t>
+              <a:t>27.01.2025</a:t>
             </a:fld>
             <a:endParaRPr lang="de-CH"/>
           </a:p>
@@ -3469,7 +3577,7 @@
           <a:p>
             <a:fld id="{A1523D7E-84BA-4532-8AC0-0461707F3C45}" type="datetime1">
               <a:rPr lang="de-CH" smtClean="0"/>
-              <a:t>21.01.2025</a:t>
+              <a:t>27.01.2025</a:t>
             </a:fld>
             <a:endParaRPr lang="de-CH"/>
           </a:p>
@@ -3785,7 +3893,7 @@
           <a:p>
             <a:fld id="{A1523D7E-84BA-4532-8AC0-0461707F3C45}" type="datetime1">
               <a:rPr lang="de-CH" smtClean="0"/>
-              <a:t>21.01.2025</a:t>
+              <a:t>27.01.2025</a:t>
             </a:fld>
             <a:endParaRPr lang="de-CH"/>
           </a:p>
@@ -4149,7 +4257,7 @@
           <a:p>
             <a:fld id="{0F06BCF4-0E81-4303-B76F-6C3D6B7E70BE}" type="datetime1">
               <a:rPr lang="de-CH" smtClean="0"/>
-              <a:t>21.01.2025</a:t>
+              <a:t>27.01.2025</a:t>
             </a:fld>
             <a:endParaRPr lang="de-CH"/>
           </a:p>
@@ -4273,7 +4381,7 @@
           <a:p>
             <a:fld id="{A1523D7E-84BA-4532-8AC0-0461707F3C45}" type="datetime1">
               <a:rPr lang="de-CH" smtClean="0"/>
-              <a:t>21.01.2025</a:t>
+              <a:t>27.01.2025</a:t>
             </a:fld>
             <a:endParaRPr lang="de-CH"/>
           </a:p>
@@ -4519,7 +4627,7 @@
             <a:fld id="{A1523D7E-84BA-4532-8AC0-0461707F3C45}" type="datetime1">
               <a:rPr lang="de-CH" smtClean="0"/>
               <a:pPr/>
-              <a:t>21.01.2025</a:t>
+              <a:t>27.01.2025</a:t>
             </a:fld>
             <a:endParaRPr lang="de-CH" dirty="0"/>
           </a:p>
@@ -5224,6 +5332,464 @@
   <p:cSld>
     <p:spTree>
       <p:nvGrpSpPr>
+        <p:cNvPr id="1" name="">
+          <a:extLst>
+            <a:ext uri="{FF2B5EF4-FFF2-40B4-BE49-F238E27FC236}">
+              <a16:creationId xmlns:a16="http://schemas.microsoft.com/office/drawing/2014/main" id="{BBB96FAC-38B2-98F9-8E20-7B904C444F46}"/>
+            </a:ext>
+          </a:extLst>
+        </p:cNvPr>
+        <p:cNvGrpSpPr/>
+        <p:nvPr/>
+      </p:nvGrpSpPr>
+      <p:grpSpPr>
+        <a:xfrm>
+          <a:off x="0" y="0"/>
+          <a:ext cx="0" cy="0"/>
+          <a:chOff x="0" y="0"/>
+          <a:chExt cx="0" cy="0"/>
+        </a:xfrm>
+      </p:grpSpPr>
+      <p:sp>
+        <p:nvSpPr>
+          <p:cNvPr id="2" name="Titel 1">
+            <a:extLst>
+              <a:ext uri="{FF2B5EF4-FFF2-40B4-BE49-F238E27FC236}">
+                <a16:creationId xmlns:a16="http://schemas.microsoft.com/office/drawing/2014/main" id="{A051714A-0E26-E6D5-DB70-BC45D692265C}"/>
+              </a:ext>
+            </a:extLst>
+          </p:cNvPr>
+          <p:cNvSpPr>
+            <a:spLocks noGrp="1"/>
+          </p:cNvSpPr>
+          <p:nvPr>
+            <p:ph type="title"/>
+          </p:nvPr>
+        </p:nvSpPr>
+        <p:spPr/>
+        <p:txBody>
+          <a:bodyPr/>
+          <a:lstStyle/>
+          <a:p>
+            <a:r>
+              <a:rPr lang="de-CH" dirty="0" err="1"/>
+              <a:t>Recap</a:t>
+            </a:r>
+            <a:r>
+              <a:rPr lang="de-CH" dirty="0"/>
+              <a:t>: Theorie-Inputs</a:t>
+            </a:r>
+            <a:endParaRPr lang="LID4096" dirty="0"/>
+          </a:p>
+        </p:txBody>
+      </p:sp>
+      <p:sp>
+        <p:nvSpPr>
+          <p:cNvPr id="5" name="Foliennummernplatzhalter 4">
+            <a:extLst>
+              <a:ext uri="{FF2B5EF4-FFF2-40B4-BE49-F238E27FC236}">
+                <a16:creationId xmlns:a16="http://schemas.microsoft.com/office/drawing/2014/main" id="{EF144769-756E-C3D9-789E-C033A8812053}"/>
+              </a:ext>
+            </a:extLst>
+          </p:cNvPr>
+          <p:cNvSpPr>
+            <a:spLocks noGrp="1"/>
+          </p:cNvSpPr>
+          <p:nvPr>
+            <p:ph type="sldNum" sz="quarter" idx="12"/>
+          </p:nvPr>
+        </p:nvSpPr>
+        <p:spPr/>
+        <p:txBody>
+          <a:bodyPr/>
+          <a:lstStyle/>
+          <a:p>
+            <a:fld id="{BC947631-D23E-4F68-A65A-9F8E25610249}" type="slidenum">
+              <a:rPr lang="de-CH" smtClean="0"/>
+              <a:t>2</a:t>
+            </a:fld>
+            <a:endParaRPr lang="de-CH"/>
+          </a:p>
+        </p:txBody>
+      </p:sp>
+      <p:sp>
+        <p:nvSpPr>
+          <p:cNvPr id="3" name="Inhaltsplatzhalter 2">
+            <a:extLst>
+              <a:ext uri="{FF2B5EF4-FFF2-40B4-BE49-F238E27FC236}">
+                <a16:creationId xmlns:a16="http://schemas.microsoft.com/office/drawing/2014/main" id="{9AAD4EFB-4E49-26DA-5440-CF10EC87F3C7}"/>
+              </a:ext>
+            </a:extLst>
+          </p:cNvPr>
+          <p:cNvSpPr>
+            <a:spLocks noGrp="1"/>
+          </p:cNvSpPr>
+          <p:nvPr>
+            <p:ph idx="1"/>
+          </p:nvPr>
+        </p:nvSpPr>
+        <p:spPr/>
+        <p:txBody>
+          <a:bodyPr/>
+          <a:lstStyle/>
+          <a:p>
+            <a:r>
+              <a:rPr lang="de-CH" dirty="0"/>
+              <a:t>Data </a:t>
+            </a:r>
+            <a:r>
+              <a:rPr lang="de-CH" dirty="0" err="1"/>
+              <a:t>Fetching</a:t>
+            </a:r>
+            <a:endParaRPr lang="de-CH" dirty="0"/>
+          </a:p>
+          <a:p>
+            <a:r>
+              <a:rPr lang="de-CH" dirty="0"/>
+              <a:t>Browser-APIs: Webcam, Geolocation, …</a:t>
+            </a:r>
+          </a:p>
+          <a:p>
+            <a:r>
+              <a:rPr lang="de-CH" dirty="0"/>
+              <a:t>Maps mit </a:t>
+            </a:r>
+            <a:r>
+              <a:rPr lang="de-CH" dirty="0" err="1"/>
+              <a:t>Leaflet</a:t>
+            </a:r>
+            <a:endParaRPr lang="de-CH" dirty="0"/>
+          </a:p>
+          <a:p>
+            <a:r>
+              <a:rPr lang="de-CH" dirty="0"/>
+              <a:t>Integration von </a:t>
+            </a:r>
+            <a:r>
+              <a:rPr lang="de-CH" dirty="0" err="1"/>
+              <a:t>Machine</a:t>
+            </a:r>
+            <a:r>
+              <a:rPr lang="de-CH" dirty="0"/>
+              <a:t> Learning Modellen</a:t>
+            </a:r>
+          </a:p>
+          <a:p>
+            <a:endParaRPr lang="de-CH" dirty="0"/>
+          </a:p>
+          <a:p>
+            <a:r>
+              <a:rPr lang="de-CH" dirty="0"/>
+              <a:t>Danach eigenständiges Projekt in Einzelarbeit</a:t>
+            </a:r>
+          </a:p>
+          <a:p>
+            <a:endParaRPr lang="de-CH" dirty="0"/>
+          </a:p>
+          <a:p>
+            <a:endParaRPr lang="de-CH" dirty="0"/>
+          </a:p>
+          <a:p>
+            <a:endParaRPr lang="LID4096" dirty="0"/>
+          </a:p>
+        </p:txBody>
+      </p:sp>
+    </p:spTree>
+    <p:extLst>
+      <p:ext uri="{BB962C8B-B14F-4D97-AF65-F5344CB8AC3E}">
+        <p14:creationId xmlns:p14="http://schemas.microsoft.com/office/powerpoint/2010/main" val="302407057"/>
+      </p:ext>
+    </p:extLst>
+  </p:cSld>
+  <p:clrMapOvr>
+    <a:masterClrMapping/>
+  </p:clrMapOvr>
+  <p:timing>
+    <p:tnLst>
+      <p:par>
+        <p:cTn id="1" dur="indefinite" restart="never" nodeType="tmRoot">
+          <p:childTnLst>
+            <p:seq concurrent="1" nextAc="seek">
+              <p:cTn id="2" dur="indefinite" nodeType="mainSeq">
+                <p:childTnLst>
+                  <p:par>
+                    <p:cTn id="3" fill="hold">
+                      <p:stCondLst>
+                        <p:cond delay="indefinite"/>
+                      </p:stCondLst>
+                      <p:childTnLst>
+                        <p:par>
+                          <p:cTn id="4" fill="hold">
+                            <p:stCondLst>
+                              <p:cond delay="0"/>
+                            </p:stCondLst>
+                            <p:childTnLst>
+                              <p:par>
+                                <p:cTn id="5" presetID="1" presetClass="entr" presetSubtype="0" fill="hold" grpId="0" nodeType="clickEffect">
+                                  <p:stCondLst>
+                                    <p:cond delay="0"/>
+                                  </p:stCondLst>
+                                  <p:childTnLst>
+                                    <p:set>
+                                      <p:cBhvr>
+                                        <p:cTn id="6" dur="1" fill="hold">
+                                          <p:stCondLst>
+                                            <p:cond delay="0"/>
+                                          </p:stCondLst>
+                                        </p:cTn>
+                                        <p:tgtEl>
+                                          <p:spTgt spid="3">
+                                            <p:txEl>
+                                              <p:pRg st="0" end="0"/>
+                                            </p:txEl>
+                                          </p:spTgt>
+                                        </p:tgtEl>
+                                        <p:attrNameLst>
+                                          <p:attrName>style.visibility</p:attrName>
+                                        </p:attrNameLst>
+                                      </p:cBhvr>
+                                      <p:to>
+                                        <p:strVal val="visible"/>
+                                      </p:to>
+                                    </p:set>
+                                  </p:childTnLst>
+                                </p:cTn>
+                              </p:par>
+                            </p:childTnLst>
+                          </p:cTn>
+                        </p:par>
+                      </p:childTnLst>
+                    </p:cTn>
+                  </p:par>
+                  <p:par>
+                    <p:cTn id="7" fill="hold">
+                      <p:stCondLst>
+                        <p:cond delay="indefinite"/>
+                      </p:stCondLst>
+                      <p:childTnLst>
+                        <p:par>
+                          <p:cTn id="8" fill="hold">
+                            <p:stCondLst>
+                              <p:cond delay="0"/>
+                            </p:stCondLst>
+                            <p:childTnLst>
+                              <p:par>
+                                <p:cTn id="9" presetID="1" presetClass="entr" presetSubtype="0" fill="hold" grpId="0" nodeType="clickEffect">
+                                  <p:stCondLst>
+                                    <p:cond delay="0"/>
+                                  </p:stCondLst>
+                                  <p:childTnLst>
+                                    <p:set>
+                                      <p:cBhvr>
+                                        <p:cTn id="10" dur="1" fill="hold">
+                                          <p:stCondLst>
+                                            <p:cond delay="0"/>
+                                          </p:stCondLst>
+                                        </p:cTn>
+                                        <p:tgtEl>
+                                          <p:spTgt spid="3">
+                                            <p:txEl>
+                                              <p:pRg st="1" end="1"/>
+                                            </p:txEl>
+                                          </p:spTgt>
+                                        </p:tgtEl>
+                                        <p:attrNameLst>
+                                          <p:attrName>style.visibility</p:attrName>
+                                        </p:attrNameLst>
+                                      </p:cBhvr>
+                                      <p:to>
+                                        <p:strVal val="visible"/>
+                                      </p:to>
+                                    </p:set>
+                                  </p:childTnLst>
+                                </p:cTn>
+                              </p:par>
+                            </p:childTnLst>
+                          </p:cTn>
+                        </p:par>
+                      </p:childTnLst>
+                    </p:cTn>
+                  </p:par>
+                  <p:par>
+                    <p:cTn id="11" fill="hold">
+                      <p:stCondLst>
+                        <p:cond delay="indefinite"/>
+                      </p:stCondLst>
+                      <p:childTnLst>
+                        <p:par>
+                          <p:cTn id="12" fill="hold">
+                            <p:stCondLst>
+                              <p:cond delay="0"/>
+                            </p:stCondLst>
+                            <p:childTnLst>
+                              <p:par>
+                                <p:cTn id="13" presetID="1" presetClass="entr" presetSubtype="0" fill="hold" grpId="0" nodeType="clickEffect">
+                                  <p:stCondLst>
+                                    <p:cond delay="0"/>
+                                  </p:stCondLst>
+                                  <p:childTnLst>
+                                    <p:set>
+                                      <p:cBhvr>
+                                        <p:cTn id="14" dur="1" fill="hold">
+                                          <p:stCondLst>
+                                            <p:cond delay="0"/>
+                                          </p:stCondLst>
+                                        </p:cTn>
+                                        <p:tgtEl>
+                                          <p:spTgt spid="3">
+                                            <p:txEl>
+                                              <p:pRg st="2" end="2"/>
+                                            </p:txEl>
+                                          </p:spTgt>
+                                        </p:tgtEl>
+                                        <p:attrNameLst>
+                                          <p:attrName>style.visibility</p:attrName>
+                                        </p:attrNameLst>
+                                      </p:cBhvr>
+                                      <p:to>
+                                        <p:strVal val="visible"/>
+                                      </p:to>
+                                    </p:set>
+                                  </p:childTnLst>
+                                </p:cTn>
+                              </p:par>
+                            </p:childTnLst>
+                          </p:cTn>
+                        </p:par>
+                      </p:childTnLst>
+                    </p:cTn>
+                  </p:par>
+                  <p:par>
+                    <p:cTn id="15" fill="hold">
+                      <p:stCondLst>
+                        <p:cond delay="indefinite"/>
+                      </p:stCondLst>
+                      <p:childTnLst>
+                        <p:par>
+                          <p:cTn id="16" fill="hold">
+                            <p:stCondLst>
+                              <p:cond delay="0"/>
+                            </p:stCondLst>
+                            <p:childTnLst>
+                              <p:par>
+                                <p:cTn id="17" presetID="1" presetClass="entr" presetSubtype="0" fill="hold" grpId="0" nodeType="clickEffect">
+                                  <p:stCondLst>
+                                    <p:cond delay="0"/>
+                                  </p:stCondLst>
+                                  <p:childTnLst>
+                                    <p:set>
+                                      <p:cBhvr>
+                                        <p:cTn id="18" dur="1" fill="hold">
+                                          <p:stCondLst>
+                                            <p:cond delay="0"/>
+                                          </p:stCondLst>
+                                        </p:cTn>
+                                        <p:tgtEl>
+                                          <p:spTgt spid="3">
+                                            <p:txEl>
+                                              <p:pRg st="3" end="3"/>
+                                            </p:txEl>
+                                          </p:spTgt>
+                                        </p:tgtEl>
+                                        <p:attrNameLst>
+                                          <p:attrName>style.visibility</p:attrName>
+                                        </p:attrNameLst>
+                                      </p:cBhvr>
+                                      <p:to>
+                                        <p:strVal val="visible"/>
+                                      </p:to>
+                                    </p:set>
+                                  </p:childTnLst>
+                                </p:cTn>
+                              </p:par>
+                            </p:childTnLst>
+                          </p:cTn>
+                        </p:par>
+                      </p:childTnLst>
+                    </p:cTn>
+                  </p:par>
+                  <p:par>
+                    <p:cTn id="19" fill="hold">
+                      <p:stCondLst>
+                        <p:cond delay="indefinite"/>
+                      </p:stCondLst>
+                      <p:childTnLst>
+                        <p:par>
+                          <p:cTn id="20" fill="hold">
+                            <p:stCondLst>
+                              <p:cond delay="0"/>
+                            </p:stCondLst>
+                            <p:childTnLst>
+                              <p:par>
+                                <p:cTn id="21" presetID="1" presetClass="entr" presetSubtype="0" fill="hold" grpId="0" nodeType="clickEffect">
+                                  <p:stCondLst>
+                                    <p:cond delay="0"/>
+                                  </p:stCondLst>
+                                  <p:childTnLst>
+                                    <p:set>
+                                      <p:cBhvr>
+                                        <p:cTn id="22" dur="1" fill="hold">
+                                          <p:stCondLst>
+                                            <p:cond delay="0"/>
+                                          </p:stCondLst>
+                                        </p:cTn>
+                                        <p:tgtEl>
+                                          <p:spTgt spid="3">
+                                            <p:txEl>
+                                              <p:pRg st="5" end="5"/>
+                                            </p:txEl>
+                                          </p:spTgt>
+                                        </p:tgtEl>
+                                        <p:attrNameLst>
+                                          <p:attrName>style.visibility</p:attrName>
+                                        </p:attrNameLst>
+                                      </p:cBhvr>
+                                      <p:to>
+                                        <p:strVal val="visible"/>
+                                      </p:to>
+                                    </p:set>
+                                  </p:childTnLst>
+                                </p:cTn>
+                              </p:par>
+                            </p:childTnLst>
+                          </p:cTn>
+                        </p:par>
+                      </p:childTnLst>
+                    </p:cTn>
+                  </p:par>
+                </p:childTnLst>
+              </p:cTn>
+              <p:prevCondLst>
+                <p:cond evt="onPrev" delay="0">
+                  <p:tgtEl>
+                    <p:sldTgt/>
+                  </p:tgtEl>
+                </p:cond>
+              </p:prevCondLst>
+              <p:nextCondLst>
+                <p:cond evt="onNext" delay="0">
+                  <p:tgtEl>
+                    <p:sldTgt/>
+                  </p:tgtEl>
+                </p:cond>
+              </p:nextCondLst>
+            </p:seq>
+          </p:childTnLst>
+        </p:cTn>
+      </p:par>
+    </p:tnLst>
+    <p:bldLst>
+      <p:bldP spid="3" grpId="0" build="p"/>
+    </p:bldLst>
+  </p:timing>
+</p:sld>
+</file>
+
+<file path=ppt/slides/slide3.xml><?xml version="1.0" encoding="utf-8"?>
+<p:sld xmlns:a="http://schemas.openxmlformats.org/drawingml/2006/main" xmlns:r="http://schemas.openxmlformats.org/officeDocument/2006/relationships" xmlns:p="http://schemas.openxmlformats.org/presentationml/2006/main">
+  <p:cSld>
+    <p:spTree>
+      <p:nvGrpSpPr>
         <p:cNvPr id="1" name=""/>
         <p:cNvGrpSpPr/>
         <p:nvPr/>
@@ -5289,7 +5855,7 @@
             <a:fld id="{BEDEFE6B-CD47-48D6-8858-514CE6C5B606}" type="slidenum">
               <a:rPr lang="de-CH" smtClean="0"/>
               <a:pPr/>
-              <a:t>2</a:t>
+              <a:t>3</a:t>
             </a:fld>
             <a:endParaRPr lang="de-CH" dirty="0"/>
           </a:p>
@@ -5435,7 +6001,7 @@
 </p:sld>
 </file>
 
-<file path=ppt/slides/slide3.xml><?xml version="1.0" encoding="utf-8"?>
+<file path=ppt/slides/slide4.xml><?xml version="1.0" encoding="utf-8"?>
 <p:sld xmlns:a="http://schemas.openxmlformats.org/drawingml/2006/main" xmlns:r="http://schemas.openxmlformats.org/officeDocument/2006/relationships" xmlns:p="http://schemas.openxmlformats.org/presentationml/2006/main">
   <p:cSld>
     <p:spTree>
@@ -5515,8 +6081,12 @@
           <a:lstStyle/>
           <a:p>
             <a:r>
+              <a:rPr lang="de-CH" dirty="0" err="1"/>
+              <a:t>Recap</a:t>
+            </a:r>
+            <a:r>
               <a:rPr lang="de-CH" dirty="0"/>
-              <a:t>Daten abfragen in JS</a:t>
+              <a:t>: Daten abfragen in JS</a:t>
             </a:r>
             <a:endParaRPr lang="LID4096" dirty="0"/>
           </a:p>
@@ -5546,7 +6116,7 @@
             <a:fld id="{7759694E-24C5-490B-A8F1-97FE52F5A3A6}" type="slidenum">
               <a:rPr lang="de-CH" smtClean="0"/>
               <a:pPr/>
-              <a:t>3</a:t>
+              <a:t>4</a:t>
             </a:fld>
             <a:endParaRPr lang="de-CH" dirty="0"/>
           </a:p>
@@ -5598,7 +6168,7 @@
 </p:sld>
 </file>
 
-<file path=ppt/slides/slide4.xml><?xml version="1.0" encoding="utf-8"?>
+<file path=ppt/slides/slide5.xml><?xml version="1.0" encoding="utf-8"?>
 <p:sld xmlns:a="http://schemas.openxmlformats.org/drawingml/2006/main" xmlns:r="http://schemas.openxmlformats.org/officeDocument/2006/relationships" xmlns:p="http://schemas.openxmlformats.org/presentationml/2006/main">
   <p:cSld>
     <p:spTree>
@@ -5637,8 +6207,12 @@
           <a:lstStyle/>
           <a:p>
             <a:r>
+              <a:rPr lang="de-CH" dirty="0" err="1"/>
+              <a:t>Recap</a:t>
+            </a:r>
+            <a:r>
               <a:rPr lang="de-CH" dirty="0"/>
-              <a:t>Aufgabe</a:t>
+              <a:t>: Aufgabe</a:t>
             </a:r>
             <a:endParaRPr lang="LID4096" dirty="0"/>
           </a:p>
@@ -5668,7 +6242,7 @@
             <a:fld id="{7759694E-24C5-490B-A8F1-97FE52F5A3A6}" type="slidenum">
               <a:rPr lang="de-CH" smtClean="0"/>
               <a:pPr/>
-              <a:t>4</a:t>
+              <a:t>5</a:t>
             </a:fld>
             <a:endParaRPr lang="de-CH" dirty="0"/>
           </a:p>
@@ -5719,7 +6293,7 @@
 </p:sld>
 </file>
 
-<file path=ppt/slides/slide5.xml><?xml version="1.0" encoding="utf-8"?>
+<file path=ppt/slides/slide6.xml><?xml version="1.0" encoding="utf-8"?>
 <p:sld xmlns:a="http://schemas.openxmlformats.org/drawingml/2006/main" xmlns:r="http://schemas.openxmlformats.org/officeDocument/2006/relationships" xmlns:p="http://schemas.openxmlformats.org/presentationml/2006/main">
   <p:cSld>
     <p:spTree>
@@ -5789,7 +6363,7 @@
             <a:fld id="{BEDEFE6B-CD47-48D6-8858-514CE6C5B606}" type="slidenum">
               <a:rPr lang="de-CH" smtClean="0"/>
               <a:pPr/>
-              <a:t>5</a:t>
+              <a:t>6</a:t>
             </a:fld>
             <a:endParaRPr lang="de-CH" dirty="0"/>
           </a:p>
@@ -5978,183 +6552,6 @@
 </p:sld>
 </file>
 
-<file path=ppt/slides/slide6.xml><?xml version="1.0" encoding="utf-8"?>
-<p:sld xmlns:a="http://schemas.openxmlformats.org/drawingml/2006/main" xmlns:r="http://schemas.openxmlformats.org/officeDocument/2006/relationships" xmlns:p="http://schemas.openxmlformats.org/presentationml/2006/main">
-  <p:cSld>
-    <p:spTree>
-      <p:nvGrpSpPr>
-        <p:cNvPr id="1" name=""/>
-        <p:cNvGrpSpPr/>
-        <p:nvPr/>
-      </p:nvGrpSpPr>
-      <p:grpSpPr>
-        <a:xfrm>
-          <a:off x="0" y="0"/>
-          <a:ext cx="0" cy="0"/>
-          <a:chOff x="0" y="0"/>
-          <a:chExt cx="0" cy="0"/>
-        </a:xfrm>
-      </p:grpSpPr>
-      <p:sp>
-        <p:nvSpPr>
-          <p:cNvPr id="2" name="Titel 1">
-            <a:extLst>
-              <a:ext uri="{FF2B5EF4-FFF2-40B4-BE49-F238E27FC236}">
-                <a16:creationId xmlns:a16="http://schemas.microsoft.com/office/drawing/2014/main" id="{2433105B-6971-2A96-5C1F-8C832C44E6F3}"/>
-              </a:ext>
-            </a:extLst>
-          </p:cNvPr>
-          <p:cNvSpPr>
-            <a:spLocks noGrp="1"/>
-          </p:cNvSpPr>
-          <p:nvPr>
-            <p:ph type="title"/>
-          </p:nvPr>
-        </p:nvSpPr>
-        <p:spPr/>
-        <p:txBody>
-          <a:bodyPr/>
-          <a:lstStyle/>
-          <a:p>
-            <a:r>
-              <a:rPr lang="de-CH" dirty="0"/>
-              <a:t>Aufgabe</a:t>
-            </a:r>
-            <a:endParaRPr lang="LID4096" dirty="0"/>
-          </a:p>
-        </p:txBody>
-      </p:sp>
-      <p:sp>
-        <p:nvSpPr>
-          <p:cNvPr id="3" name="Foliennummernplatzhalter 2">
-            <a:extLst>
-              <a:ext uri="{FF2B5EF4-FFF2-40B4-BE49-F238E27FC236}">
-                <a16:creationId xmlns:a16="http://schemas.microsoft.com/office/drawing/2014/main" id="{D5AD0757-AB84-5D42-795F-BC036A245C99}"/>
-              </a:ext>
-            </a:extLst>
-          </p:cNvPr>
-          <p:cNvSpPr>
-            <a:spLocks noGrp="1"/>
-          </p:cNvSpPr>
-          <p:nvPr>
-            <p:ph type="sldNum" sz="quarter" idx="12"/>
-          </p:nvPr>
-        </p:nvSpPr>
-        <p:spPr/>
-        <p:txBody>
-          <a:bodyPr/>
-          <a:lstStyle/>
-          <a:p>
-            <a:fld id="{7759694E-24C5-490B-A8F1-97FE52F5A3A6}" type="slidenum">
-              <a:rPr lang="de-CH" smtClean="0"/>
-              <a:pPr/>
-              <a:t>6</a:t>
-            </a:fld>
-            <a:endParaRPr lang="de-CH" dirty="0"/>
-          </a:p>
-        </p:txBody>
-      </p:sp>
-      <p:sp>
-        <p:nvSpPr>
-          <p:cNvPr id="4" name="Inhaltsplatzhalter 3">
-            <a:extLst>
-              <a:ext uri="{FF2B5EF4-FFF2-40B4-BE49-F238E27FC236}">
-                <a16:creationId xmlns:a16="http://schemas.microsoft.com/office/drawing/2014/main" id="{CFD97E8F-419E-4C37-5E31-FB3C266A40BA}"/>
-              </a:ext>
-            </a:extLst>
-          </p:cNvPr>
-          <p:cNvSpPr>
-            <a:spLocks noGrp="1"/>
-          </p:cNvSpPr>
-          <p:nvPr>
-            <p:ph idx="1"/>
-          </p:nvPr>
-        </p:nvSpPr>
-        <p:spPr/>
-        <p:txBody>
-          <a:bodyPr/>
-          <a:lstStyle/>
-          <a:p>
-            <a:r>
-              <a:rPr lang="de-CH" dirty="0"/>
-              <a:t>Finde heraus auf welcher Höhe über Meer der aktuelle Standort des Clients liegt.</a:t>
-            </a:r>
-            <a:br>
-              <a:rPr lang="de-CH" dirty="0"/>
-            </a:br>
-            <a:r>
-              <a:rPr lang="de-CH" dirty="0"/>
-              <a:t>(Tipp: </a:t>
-            </a:r>
-            <a:r>
-              <a:rPr lang="de-CH" dirty="0">
-                <a:hlinkClick r:id="rId2"/>
-              </a:rPr>
-              <a:t>swisstopo.admin.ch/en/</a:t>
-            </a:r>
-            <a:r>
-              <a:rPr lang="de-CH" dirty="0" err="1">
-                <a:hlinkClick r:id="rId2"/>
-              </a:rPr>
-              <a:t>coordinates-conversion-navref</a:t>
-            </a:r>
-            <a:r>
-              <a:rPr lang="de-CH" dirty="0"/>
-              <a:t>)</a:t>
-            </a:r>
-          </a:p>
-          <a:p>
-            <a:r>
-              <a:rPr lang="de-CH" dirty="0"/>
-              <a:t>Bonus: Versuche es mit anderen Standorten</a:t>
-            </a:r>
-            <a:br>
-              <a:rPr lang="de-CH" dirty="0"/>
-            </a:br>
-            <a:r>
-              <a:rPr lang="de-CH" dirty="0"/>
-              <a:t>(Location </a:t>
-            </a:r>
-            <a:r>
-              <a:rPr lang="de-CH" dirty="0" err="1"/>
-              <a:t>Override</a:t>
-            </a:r>
-            <a:r>
-              <a:rPr lang="de-CH" dirty="0"/>
-              <a:t>)</a:t>
-            </a:r>
-          </a:p>
-          <a:p>
-            <a:r>
-              <a:rPr lang="de-CH" dirty="0"/>
-              <a:t>Experimentiere mit CSS Filtern um den</a:t>
-            </a:r>
-            <a:br>
-              <a:rPr lang="de-CH" dirty="0"/>
-            </a:br>
-            <a:r>
-              <a:rPr lang="de-CH" dirty="0"/>
-              <a:t>Webcam-Stream visuell zu verändern.</a:t>
-            </a:r>
-          </a:p>
-          <a:p>
-            <a:endParaRPr lang="LID4096" dirty="0"/>
-          </a:p>
-        </p:txBody>
-      </p:sp>
-    </p:spTree>
-    <p:extLst>
-      <p:ext uri="{BB962C8B-B14F-4D97-AF65-F5344CB8AC3E}">
-        <p14:creationId xmlns:p14="http://schemas.microsoft.com/office/powerpoint/2010/main" val="2954482878"/>
-      </p:ext>
-    </p:extLst>
-  </p:cSld>
-  <p:clrMapOvr>
-    <a:masterClrMapping/>
-  </p:clrMapOvr>
-</p:sld>
-</file>
-
 <file path=ppt/slides/slide7.xml><?xml version="1.0" encoding="utf-8"?>
 <p:sld xmlns:a="http://schemas.openxmlformats.org/drawingml/2006/main" xmlns:r="http://schemas.openxmlformats.org/officeDocument/2006/relationships" xmlns:p="http://schemas.openxmlformats.org/presentationml/2006/main">
   <p:cSld>
@@ -6177,7 +6574,7 @@
           <p:cNvPr id="2" name="Titel 1">
             <a:extLst>
               <a:ext uri="{FF2B5EF4-FFF2-40B4-BE49-F238E27FC236}">
-                <a16:creationId xmlns:a16="http://schemas.microsoft.com/office/drawing/2014/main" id="{A069C0B9-618E-3C61-A53A-420DF6F841E4}"/>
+                <a16:creationId xmlns:a16="http://schemas.microsoft.com/office/drawing/2014/main" id="{2433105B-6971-2A96-5C1F-8C832C44E6F3}"/>
               </a:ext>
             </a:extLst>
           </p:cNvPr>
@@ -6195,11 +6592,7 @@
           <a:p>
             <a:r>
               <a:rPr lang="de-CH" dirty="0"/>
-              <a:t>Maps mit </a:t>
-            </a:r>
-            <a:r>
-              <a:rPr lang="de-CH" dirty="0" err="1"/>
-              <a:t>Leaflet</a:t>
+              <a:t>Aufgabe</a:t>
             </a:r>
             <a:endParaRPr lang="LID4096" dirty="0"/>
           </a:p>
@@ -6210,7 +6603,7 @@
           <p:cNvPr id="3" name="Foliennummernplatzhalter 2">
             <a:extLst>
               <a:ext uri="{FF2B5EF4-FFF2-40B4-BE49-F238E27FC236}">
-                <a16:creationId xmlns:a16="http://schemas.microsoft.com/office/drawing/2014/main" id="{A43BB501-C5C5-DCCE-F40C-3E1D70C8BF0D}"/>
+                <a16:creationId xmlns:a16="http://schemas.microsoft.com/office/drawing/2014/main" id="{D5AD0757-AB84-5D42-795F-BC036A245C99}"/>
               </a:ext>
             </a:extLst>
           </p:cNvPr>
@@ -6240,7 +6633,7 @@
           <p:cNvPr id="4" name="Inhaltsplatzhalter 3">
             <a:extLst>
               <a:ext uri="{FF2B5EF4-FFF2-40B4-BE49-F238E27FC236}">
-                <a16:creationId xmlns:a16="http://schemas.microsoft.com/office/drawing/2014/main" id="{0DCAA51D-787E-2082-B990-3BEBE6D70286}"/>
+                <a16:creationId xmlns:a16="http://schemas.microsoft.com/office/drawing/2014/main" id="{CFD97E8F-419E-4C37-5E31-FB3C266A40BA}"/>
               </a:ext>
             </a:extLst>
           </p:cNvPr>
@@ -6251,92 +6644,82 @@
             <p:ph idx="1"/>
           </p:nvPr>
         </p:nvSpPr>
-        <p:spPr>
-          <a:xfrm>
-            <a:off x="838200" y="2902527"/>
-            <a:ext cx="10515600" cy="3407291"/>
-          </a:xfrm>
-        </p:spPr>
-        <p:txBody>
-          <a:bodyPr/>
-          <a:lstStyle/>
-          <a:p>
+        <p:spPr/>
+        <p:txBody>
+          <a:bodyPr/>
+          <a:lstStyle/>
+          <a:p>
+            <a:r>
+              <a:rPr lang="de-CH" dirty="0"/>
+              <a:t>Finde heraus auf welcher Höhe über Meer der aktuelle Standort des Clients liegt.</a:t>
+            </a:r>
+            <a:br>
+              <a:rPr lang="de-CH" dirty="0"/>
+            </a:br>
+            <a:r>
+              <a:rPr lang="de-CH" dirty="0"/>
+              <a:t>(Tipp: </a:t>
+            </a:r>
             <a:r>
               <a:rPr lang="de-CH" dirty="0">
                 <a:hlinkClick r:id="rId2"/>
               </a:rPr>
-              <a:t>https://leafletjs.com</a:t>
-            </a:r>
-            <a:endParaRPr lang="de-CH" dirty="0"/>
-          </a:p>
-          <a:p>
-            <a:endParaRPr lang="de-CH" dirty="0"/>
-          </a:p>
-          <a:p>
-            <a:r>
-              <a:rPr lang="de-CH" dirty="0">
-                <a:hlinkClick r:id="rId3"/>
+              <a:t>swisstopo.admin.ch/en/</a:t>
+            </a:r>
+            <a:r>
+              <a:rPr lang="de-CH" dirty="0" err="1">
+                <a:hlinkClick r:id="rId2"/>
               </a:rPr>
-              <a:t>https://api3.geo.admin.ch/api/examples.html#other-js-web-mapping-apis-integration</a:t>
-            </a:r>
-            <a:endParaRPr lang="de-CH" dirty="0"/>
+              <a:t>coordinates-conversion-navref</a:t>
+            </a:r>
+            <a:r>
+              <a:rPr lang="de-CH" dirty="0"/>
+              <a:t>)</a:t>
+            </a:r>
+          </a:p>
+          <a:p>
+            <a:r>
+              <a:rPr lang="de-CH" dirty="0"/>
+              <a:t>Bonus: Versuche es mit anderen Standorten</a:t>
+            </a:r>
+            <a:br>
+              <a:rPr lang="de-CH" dirty="0"/>
+            </a:br>
+            <a:r>
+              <a:rPr lang="de-CH" dirty="0"/>
+              <a:t>(Location </a:t>
+            </a:r>
+            <a:r>
+              <a:rPr lang="de-CH" dirty="0" err="1"/>
+              <a:t>Override</a:t>
+            </a:r>
+            <a:r>
+              <a:rPr lang="de-CH" dirty="0"/>
+              <a:t>)</a:t>
+            </a:r>
+          </a:p>
+          <a:p>
+            <a:r>
+              <a:rPr lang="de-CH" dirty="0"/>
+              <a:t>Experimentiere mit CSS Filtern um den</a:t>
+            </a:r>
+            <a:br>
+              <a:rPr lang="de-CH" dirty="0"/>
+            </a:br>
+            <a:r>
+              <a:rPr lang="de-CH" dirty="0"/>
+              <a:t>Webcam-Stream visuell zu verändern.</a:t>
+            </a:r>
           </a:p>
           <a:p>
             <a:endParaRPr lang="LID4096" dirty="0"/>
           </a:p>
         </p:txBody>
       </p:sp>
-      <p:pic>
-        <p:nvPicPr>
-          <p:cNvPr id="1026" name="Picture 2" descr="Leaflet">
-            <a:extLst>
-              <a:ext uri="{FF2B5EF4-FFF2-40B4-BE49-F238E27FC236}">
-                <a16:creationId xmlns:a16="http://schemas.microsoft.com/office/drawing/2014/main" id="{A28927F7-7125-8EB6-8C44-B88AAD0F5F2A}"/>
-              </a:ext>
-            </a:extLst>
-          </p:cNvPr>
-          <p:cNvPicPr>
-            <a:picLocks noChangeAspect="1" noChangeArrowheads="1"/>
-          </p:cNvPicPr>
-          <p:nvPr/>
-        </p:nvPicPr>
-        <p:blipFill>
-          <a:blip r:embed="rId4">
-            <a:extLst>
-              <a:ext uri="{28A0092B-C50C-407E-A947-70E740481C1C}">
-                <a14:useLocalDpi xmlns:a14="http://schemas.microsoft.com/office/drawing/2010/main" val="0"/>
-              </a:ext>
-            </a:extLst>
-          </a:blip>
-          <a:srcRect/>
-          <a:stretch>
-            <a:fillRect/>
-          </a:stretch>
-        </p:blipFill>
-        <p:spPr bwMode="auto">
-          <a:xfrm>
-            <a:off x="5947064" y="1829677"/>
-            <a:ext cx="5715000" cy="1514475"/>
-          </a:xfrm>
-          <a:prstGeom prst="rect">
-            <a:avLst/>
-          </a:prstGeom>
-          <a:noFill/>
-          <a:extLst>
-            <a:ext uri="{909E8E84-426E-40DD-AFC4-6F175D3DCCD1}">
-              <a14:hiddenFill xmlns:a14="http://schemas.microsoft.com/office/drawing/2010/main">
-                <a:solidFill>
-                  <a:srgbClr val="FFFFFF"/>
-                </a:solidFill>
-              </a14:hiddenFill>
-            </a:ext>
-          </a:extLst>
-        </p:spPr>
-      </p:pic>
     </p:spTree>
     <p:extLst>
       <p:ext uri="{BB962C8B-B14F-4D97-AF65-F5344CB8AC3E}">
-        <p14:creationId xmlns:p14="http://schemas.microsoft.com/office/powerpoint/2010/main" val="832415389"/>
+        <p14:creationId xmlns:p14="http://schemas.microsoft.com/office/powerpoint/2010/main" val="2954482878"/>
       </p:ext>
     </p:extLst>
   </p:cSld>
@@ -6445,7 +6828,11 @@
           <a:p>
             <a:r>
               <a:rPr lang="de-CH" dirty="0"/>
-              <a:t>Webcam und andere Features abfragen (Laptop mitnehmen!)</a:t>
+              <a:t>Maps mit </a:t>
+            </a:r>
+            <a:r>
+              <a:rPr lang="de-CH" dirty="0" err="1"/>
+              <a:t>Leaflet</a:t>
             </a:r>
             <a:endParaRPr lang="LID4096" dirty="0"/>
           </a:p>

</xml_diff>

<commit_message>
update papers for lecture 2
</commit_message>
<xml_diff>
--- a/papers/lektion-2.pptx
+++ b/papers/lektion-2.pptx
@@ -242,7 +242,7 @@
           <a:p>
             <a:fld id="{FC23D672-218E-44CF-A13C-71AB61B14F4F}" type="datetimeFigureOut">
               <a:rPr lang="de-CH" smtClean="0"/>
-              <a:t>16.01.2026</a:t>
+              <a:t>26.01.2026</a:t>
             </a:fld>
             <a:endParaRPr lang="de-CH"/>
           </a:p>
@@ -407,7 +407,7 @@
           <a:p>
             <a:fld id="{93FA598B-8DA1-4BBA-9EA9-DC1615E9868A}" type="datetimeFigureOut">
               <a:rPr lang="de-CH" smtClean="0"/>
-              <a:t>16.01.2026</a:t>
+              <a:t>26.01.2026</a:t>
             </a:fld>
             <a:endParaRPr lang="de-CH"/>
           </a:p>
@@ -1505,7 +1505,7 @@
           <a:p>
             <a:fld id="{6853F526-C1D0-4550-B781-F5C2F41E5AD9}" type="datetime1">
               <a:rPr lang="de-CH" smtClean="0"/>
-              <a:t>16.01.2026</a:t>
+              <a:t>26.01.2026</a:t>
             </a:fld>
             <a:endParaRPr lang="de-CH"/>
           </a:p>
@@ -1641,7 +1641,7 @@
           <a:p>
             <a:fld id="{A1523D7E-84BA-4532-8AC0-0461707F3C45}" type="datetime1">
               <a:rPr lang="de-CH" smtClean="0"/>
-              <a:t>16.01.2026</a:t>
+              <a:t>26.01.2026</a:t>
             </a:fld>
             <a:endParaRPr lang="de-CH"/>
           </a:p>
@@ -1799,7 +1799,7 @@
           <a:p>
             <a:fld id="{A1523D7E-84BA-4532-8AC0-0461707F3C45}" type="datetime1">
               <a:rPr lang="de-CH" smtClean="0"/>
-              <a:t>16.01.2026</a:t>
+              <a:t>26.01.2026</a:t>
             </a:fld>
             <a:endParaRPr lang="de-CH"/>
           </a:p>
@@ -2427,7 +2427,7 @@
           <a:p>
             <a:fld id="{107B2E98-33F3-4843-92CD-A9A795F13784}" type="datetime1">
               <a:rPr lang="de-CH" smtClean="0"/>
-              <a:t>16.01.2026</a:t>
+              <a:t>26.01.2026</a:t>
             </a:fld>
             <a:endParaRPr lang="de-CH"/>
           </a:p>
@@ -2556,7 +2556,7 @@
           <a:p>
             <a:fld id="{A1523D7E-84BA-4532-8AC0-0461707F3C45}" type="datetime1">
               <a:rPr lang="de-CH" smtClean="0"/>
-              <a:t>16.01.2026</a:t>
+              <a:t>26.01.2026</a:t>
             </a:fld>
             <a:endParaRPr lang="de-CH"/>
           </a:p>
@@ -3198,7 +3198,7 @@
           <a:p>
             <a:fld id="{6853F526-C1D0-4550-B781-F5C2F41E5AD9}" type="datetime1">
               <a:rPr lang="de-CH" smtClean="0"/>
-              <a:t>16.01.2026</a:t>
+              <a:t>26.01.2026</a:t>
             </a:fld>
             <a:endParaRPr lang="de-CH"/>
           </a:p>
@@ -3334,7 +3334,7 @@
           <a:p>
             <a:fld id="{A1523D7E-84BA-4532-8AC0-0461707F3C45}" type="datetime1">
               <a:rPr lang="de-CH" smtClean="0"/>
-              <a:t>16.01.2026</a:t>
+              <a:t>26.01.2026</a:t>
             </a:fld>
             <a:endParaRPr lang="de-CH"/>
           </a:p>
@@ -3577,7 +3577,7 @@
           <a:p>
             <a:fld id="{A1523D7E-84BA-4532-8AC0-0461707F3C45}" type="datetime1">
               <a:rPr lang="de-CH" smtClean="0"/>
-              <a:t>16.01.2026</a:t>
+              <a:t>26.01.2026</a:t>
             </a:fld>
             <a:endParaRPr lang="de-CH"/>
           </a:p>
@@ -3893,7 +3893,7 @@
           <a:p>
             <a:fld id="{A1523D7E-84BA-4532-8AC0-0461707F3C45}" type="datetime1">
               <a:rPr lang="de-CH" smtClean="0"/>
-              <a:t>16.01.2026</a:t>
+              <a:t>26.01.2026</a:t>
             </a:fld>
             <a:endParaRPr lang="de-CH"/>
           </a:p>
@@ -4257,7 +4257,7 @@
           <a:p>
             <a:fld id="{0F06BCF4-0E81-4303-B76F-6C3D6B7E70BE}" type="datetime1">
               <a:rPr lang="de-CH" smtClean="0"/>
-              <a:t>16.01.2026</a:t>
+              <a:t>26.01.2026</a:t>
             </a:fld>
             <a:endParaRPr lang="de-CH"/>
           </a:p>
@@ -4381,7 +4381,7 @@
           <a:p>
             <a:fld id="{A1523D7E-84BA-4532-8AC0-0461707F3C45}" type="datetime1">
               <a:rPr lang="de-CH" smtClean="0"/>
-              <a:t>16.01.2026</a:t>
+              <a:t>26.01.2026</a:t>
             </a:fld>
             <a:endParaRPr lang="de-CH"/>
           </a:p>
@@ -4627,7 +4627,7 @@
             <a:fld id="{A1523D7E-84BA-4532-8AC0-0461707F3C45}" type="datetime1">
               <a:rPr lang="de-CH" smtClean="0"/>
               <a:pPr/>
-              <a:t>16.01.2026</a:t>
+              <a:t>26.01.2026</a:t>
             </a:fld>
             <a:endParaRPr lang="de-CH" dirty="0"/>
           </a:p>
@@ -6414,17 +6414,6 @@
             </a:r>
             <a:endParaRPr lang="de-CH" dirty="0"/>
           </a:p>
-          <a:p>
-            <a:r>
-              <a:rPr lang="de-CH" dirty="0"/>
-              <a:t>Falls noch Zeit übrig: Maps mit </a:t>
-            </a:r>
-            <a:r>
-              <a:rPr lang="de-CH" dirty="0" err="1"/>
-              <a:t>Leaflet</a:t>
-            </a:r>
-            <a:endParaRPr lang="LID4096" dirty="0"/>
-          </a:p>
         </p:txBody>
       </p:sp>
     </p:spTree>
@@ -6494,55 +6483,6 @@
                       </p:childTnLst>
                     </p:cTn>
                   </p:par>
-                  <p:par>
-                    <p:cTn id="7" fill="hold">
-                      <p:stCondLst>
-                        <p:cond delay="indefinite"/>
-                      </p:stCondLst>
-                      <p:childTnLst>
-                        <p:par>
-                          <p:cTn id="8" fill="hold">
-                            <p:stCondLst>
-                              <p:cond delay="0"/>
-                            </p:stCondLst>
-                            <p:childTnLst>
-                              <p:par>
-                                <p:cTn id="9" presetID="1" presetClass="entr" presetSubtype="0" fill="hold" grpId="0" nodeType="clickEffect">
-                                  <p:stCondLst>
-                                    <p:cond delay="0"/>
-                                  </p:stCondLst>
-                                  <p:childTnLst>
-                                    <p:set>
-                                      <p:cBhvr>
-                                        <p:cTn id="10" dur="1" fill="hold">
-                                          <p:stCondLst>
-                                            <p:cond delay="0"/>
-                                          </p:stCondLst>
-                                        </p:cTn>
-                                        <p:tgtEl>
-                                          <p:spTgt spid="7">
-                                            <p:txEl>
-                                              <p:pRg st="1" end="1"/>
-                                            </p:txEl>
-                                          </p:spTgt>
-                                        </p:tgtEl>
-                                        <p:attrNameLst>
-                                          <p:attrName>style.visibility</p:attrName>
-                                        </p:attrNameLst>
-                                      </p:cBhvr>
-                                      <p:to>
-                                        <p:strVal val="visible"/>
-                                      </p:to>
-                                    </p:set>
-                                  </p:childTnLst>
-                                </p:cTn>
-                              </p:par>
-                            </p:childTnLst>
-                          </p:cTn>
-                        </p:par>
-                      </p:childTnLst>
-                    </p:cTn>
-                  </p:par>
                 </p:childTnLst>
               </p:cTn>
               <p:prevCondLst>
@@ -6729,6 +6669,31 @@
               <a:rPr lang="de-CH" dirty="0"/>
               <a:t>Webcam-Stream visuell zu verändern.</a:t>
             </a:r>
+          </a:p>
+          <a:p>
+            <a:r>
+              <a:rPr lang="de-CH" dirty="0"/>
+              <a:t>Bonus: Teste weitere APIs: </a:t>
+            </a:r>
+            <a:r>
+              <a:rPr lang="de-CH" dirty="0">
+                <a:hlinkClick r:id="rId3"/>
+              </a:rPr>
+              <a:t>List </a:t>
+            </a:r>
+            <a:r>
+              <a:rPr lang="de-CH" dirty="0" err="1">
+                <a:hlinkClick r:id="rId3"/>
+              </a:rPr>
+              <a:t>of</a:t>
+            </a:r>
+            <a:r>
+              <a:rPr lang="de-CH" dirty="0">
+                <a:hlinkClick r:id="rId3"/>
+              </a:rPr>
+              <a:t> Browser APIs - Medium</a:t>
+            </a:r>
+            <a:endParaRPr lang="de-CH" dirty="0"/>
           </a:p>
           <a:p>
             <a:endParaRPr lang="LID4096" dirty="0"/>

</xml_diff>